<commit_message>
fix: MSB flyttade karttjänsten till gis-tjanster.mcf.se (301) + docs efter go-live på subdomänen
- config.js v10: nya MSB-värden för WMS/REST (gamla gisapp.msb.se svarar 301 utan CORS)
- Subdomänen samhallsbyggare.projektledarpodden.se live (CNAME i Cloudflare, custom domain Ready)
- PLAN.md, session-log, CLAUDE.md, datakallor, pptx uppdaterade

Co-Authored-By: Claude Fable 5.1 <noreply@anthropic.com>
</commit_message>
<xml_diff>
--- a/samhallsbyggare-dokumentation.pptx
+++ b/samhallsbyggare-dokumentation.pptx
@@ -3510,7 +3510,7 @@
                 <a:ea typeface="Calibri" pitchFamily="34" charset="-122"/>
                 <a:cs typeface="Calibri" pitchFamily="34" charset="-120"/>
               </a:rPr>
-              <a:t>I drift (fungerande live-demo), publik testperiod till och med 2026-09-24. Sajten byggdes och driftsattes 2026-07-06 i fem arbetspass inkl. säkerhets-/UX-/arkitekturgranskning. 2026-09-20: subdomänen samhallsbyggare.projektledarpodden.se registreras så snart CNAME-posten ligger i Cloudflare (Mattias), QR-kod finns i docs/, och ett schemalagt GitHub Actions-jobb ersätter sajten med en stängt-sida kvällen 24 september 2026. Länsstyrelsens EBH-lager är fortfarande overifierat.</a:t>
+              <a:t>I drift på https://samhallsbyggare.projektledarpodden.se (live 2026-09-20, giltigt certifikat), publik testperiod till och med 2026-09-24. Sajten byggdes 2026-07-06 i fem arbetspass inkl. säkerhets-/UX-/arkitekturgranskning. QR-kod finns i docs/. Ett schemalagt GitHub Actions-jobb ersätter sajten med en stängt-sida kvällen 24 september 2026. Länsstyrelsens EBH-lager är fortfarande overifierat; MSB:s tjänst svarade inte vid publiceringstestet.</a:t>
             </a:r>
             <a:pPr algn="l" indent="0" marL="0">
               <a:lnSpc>
@@ -5982,7 +5982,7 @@
                 <a:ea typeface="Calibri" pitchFamily="34" charset="-122"/>
                 <a:cs typeface="Calibri" pitchFamily="34" charset="-120"/>
               </a:rPr>
-              <a:t>Mål-URL: https://samhallsbyggare.projektledarpodden.se — DNS ligger hos Cloudflare (zon projektledarpodden.se). Kräver CNAME samhallsbyggare → purple-bush-015972603.7.azurestaticapps.net (DNS only, grå moln) och därefter az staticwebapp hostname set (se PLAN.md). Avstängning: .github/workflows/stang-av-2026-09-24.yml deployar stangd/ (utan API) 24 sep 2026 kl 22; datumspärr i ordinarie deploy från 25 sep. Free-nivån kostar 0 kr oavsett.</a:t>
+              <a:t>Publik URL: https://samhallsbyggare.projektledarpodden.se — CNAME (DNS only) i Cloudflare-zonen projektledarpodden.se → purple-bush-015972603.7.azurestaticapps.net, custom domain registrerad på SWA:n (status Ready). Avstängning: .github/workflows/stang-av-2026-09-24.yml deployar stangd/ (utan API) 24 sep 2026 kl 22; datumspärr i ordinarie deploy från 25 sep. Free-nivån kostar 0 kr oavsett.</a:t>
             </a:r>
             <a:pPr algn="l" indent="0" marL="0">
               <a:lnSpc>
@@ -8347,7 +8347,7 @@
                 <a:ea typeface="Calibri" pitchFamily="34" charset="-122"/>
                 <a:cs typeface="Calibri" pitchFamily="34" charset="-120"/>
               </a:rPr>
-              <a:t>Mattias: lägg CNAME i Cloudflare (DNS only) → Claude kör az staticwebapp hostname set → testa QR-koden i docs/qr-samhallsbyggare.png</a:t>
+              <a:t>Efter 24/9: kontrollera att avstängningsjobbet gick igenom. QR-koden i docs/qr-samhallsbyggare.png kan visas i PowerPoint.</a:t>
             </a:r>
             <a:pPr algn="l" indent="0" marL="0">
               <a:lnSpc>

</xml_diff>